<commit_message>
feat: rediseño premium y optimización móvil del modal de productos
</commit_message>
<xml_diff>
--- a/docs/negocio/Dizi_PitchDeck.pptx
+++ b/docs/negocio/Dizi_PitchDeck.pptx
@@ -6421,7 +6421,7 @@
                 <a:ea typeface="Arial Black" pitchFamily="34" charset="-122"/>
                 <a:cs typeface="Arial Black" pitchFamily="34" charset="-120"/>
               </a:rPr>
-              <a:t>S/ 14.90</a:t>
+              <a:t>S/ 9.90</a:t>
             </a:r>
             <a:endParaRPr lang="en-US" sz="2600" dirty="0"/>
           </a:p>
@@ -6696,7 +6696,7 @@
                 <a:ea typeface="Arial Black" pitchFamily="34" charset="-122"/>
                 <a:cs typeface="Arial Black" pitchFamily="34" charset="-120"/>
               </a:rPr>
-              <a:t>S/ 19.90</a:t>
+              <a:t>S/ 14.90</a:t>
             </a:r>
             <a:endParaRPr lang="en-US" sz="2600" dirty="0"/>
           </a:p>

</xml_diff>